<commit_message>
Replace vendor model names with durable capability tiers
</commit_message>
<xml_diff>
--- a/01-deck/slm-class-deck.pptx
+++ b/01-deck/slm-class-deck.pptx
@@ -14721,7 +14721,7 @@
                 <a:ea typeface="Calibri" pitchFamily="34" charset="-122"/>
                 <a:cs typeface="Calibri" pitchFamily="34" charset="-120"/>
               </a:rPr>
-              <a:t>GPT-5</a:t>
+              <a:t>a leading frontier model</a:t>
             </a:r>
             <a:endParaRPr lang="en-US" sz="1250" dirty="0"/>
           </a:p>
@@ -14816,7 +14816,7 @@
                 <a:ea typeface="Calibri" pitchFamily="34" charset="-122"/>
                 <a:cs typeface="Calibri" pitchFamily="34" charset="-120"/>
               </a:rPr>
-              <a:t>Claude-4-Sonnet</a:t>
+              <a:t>a frontier mid tier model</a:t>
             </a:r>
             <a:endParaRPr lang="en-US" sz="1250" dirty="0"/>
           </a:p>
@@ -14894,7 +14894,7 @@
                 <a:ea typeface="Calibri" pitchFamily="34" charset="-122"/>
                 <a:cs typeface="Calibri" pitchFamily="34" charset="-120"/>
               </a:rPr>
-              <a:t>turns before Qwen3-32B</a:t>
+              <a:t>turns before a 32B open model</a:t>
             </a:r>
             <a:endParaRPr lang="en-US" sz="1250" dirty="0"/>
           </a:p>
@@ -16663,7 +16663,7 @@
                 <a:ea typeface="Calibri" pitchFamily="34" charset="-122"/>
                 <a:cs typeface="Calibri" pitchFamily="34" charset="-120"/>
               </a:rPr>
-              <a:t>Zed’s Zeta2 edit-prediction model is an 8B open model distilled with Claude Sonnet as teacher. The big model manufactures training data offline and never appears in the hot path. +30% acceptance rate. The most underused pattern here.</a:t>
+              <a:t>Zed’s Zeta2 edit-prediction model is an 8B open model distilled with a frontier model as teacher. The big model manufactures training data offline and never appears in the hot path. +30% acceptance rate. The most underused pattern here.</a:t>
             </a:r>
             <a:endParaRPr lang="en-US" sz="1350" dirty="0"/>
           </a:p>
@@ -20427,7 +20427,7 @@
                           <a:ea typeface="Calibri" pitchFamily="34" charset="-122"/>
                           <a:cs typeface="Calibri" pitchFamily="34" charset="-120"/>
                         </a:rPr>
-                        <a:t>Claude Opus 5  ($5 / $25)</a:t>
+                        <a:t>a frontier premium model  ($5 / $25)</a:t>
                       </a:r>
                       <a:endParaRPr lang="en-US" sz="1350" dirty="0">
                         <a:latin typeface="Calibri" charset="0"/>
@@ -20689,7 +20689,7 @@
                           <a:ea typeface="Calibri" pitchFamily="34" charset="-122"/>
                           <a:cs typeface="Calibri" pitchFamily="34" charset="-120"/>
                         </a:rPr>
-                        <a:t>Claude Sonnet 5  ($2 / $10)</a:t>
+                        <a:t>a frontier mid tier model  ($2 / $10)</a:t>
                       </a:r>
                       <a:endParaRPr lang="en-US" sz="1350" dirty="0">
                         <a:latin typeface="Calibri" charset="0"/>
@@ -20951,7 +20951,7 @@
                           <a:ea typeface="Calibri" pitchFamily="34" charset="-122"/>
                           <a:cs typeface="Calibri" pitchFamily="34" charset="-120"/>
                         </a:rPr>
-                        <a:t>Claude Haiku 4.5  ($1 / $5)</a:t>
+                        <a:t>a frontier small model  ($1 / $5)</a:t>
                       </a:r>
                       <a:endParaRPr lang="en-US" sz="1350" dirty="0">
                         <a:latin typeface="Calibri" charset="0"/>

</xml_diff>